<commit_message>
Slide 20: reframe blend sizing from 3-8% to a 10% indicative allocation
This investor may allocate >10%, so the prudent 3-8% framing undersells it.
- Regenerated the frontier chart: removed the 'prudent 3-8% zone' annotation
  and added an on-curve '10% indicative' marker (same curve/data, restyled)
- Callout: 'ADD A 10% SLEEVE' -> 7.6% return / 11.0% downside risk,
  90% MSCI / 10% Athanase (derived from the deck's own 0% and 8% points)
- Updated 'how to read it' and footer caption to drop the 3-8% discipline
  and note a ~10% sleeve lifts return ~1.5 pts while cutting downside risk

https://claude.ai/code/session_01HRMxSvt6t94q3GFGUqavQe
</commit_message>
<xml_diff>
--- a/Your_index_is_now_a_bet_on_AI_diversify_it.pptx
+++ b/Your_index_is_now_a_bet_on_AI_diversify_it.pptx
@@ -22995,7 +22995,7 @@
                 </a:solidFill>
                 <a:latin typeface="Arial"/>
               </a:rPr>
-              <a:t>ADD A PRUDENT 8% SLEEVE</a:t>
+              <a:t>ADD A 10% SLEEVE</a:t>
             </a:r>
           </a:p>
         </p:txBody>
@@ -23034,7 +23034,7 @@
                 </a:solidFill>
                 <a:latin typeface="Times New Roman"/>
               </a:rPr>
-              <a:t>7.3% return</a:t>
+              <a:t>7.6% return   ·   11.0% downside risk</a:t>
             </a:r>
             <a:r>
               <a:rPr sz="960">
@@ -23043,7 +23043,7 @@
                 </a:solidFill>
                 <a:latin typeface="Arial"/>
               </a:rPr>
-              <a:t>   ·   11.1% downside risk</a:t>
+              <a:t/>
             </a:r>
           </a:p>
         </p:txBody>
@@ -23085,7 +23085,7 @@
                 </a:solidFill>
                 <a:latin typeface="Arial"/>
               </a:rPr>
-              <a:t>92% MSCI  /  8% Athanase</a:t>
+              <a:t>90% MSCI  /  10% Athanase</a:t>
             </a:r>
           </a:p>
         </p:txBody>
@@ -23169,7 +23169,7 @@
                 </a:solidFill>
                 <a:latin typeface="Arial"/>
               </a:rPr>
-              <a:t>Every blend on the curve beats holding equities alone, and the benefit keeps building until past half the portfolio (downside risk bottoms near 60%). That is a directional case to size up — within prudent limits — not a target: a 59% position would breach concentration, liquidity and the 3–8% sizing discipline. Even an 8% sleeve already moves the portfolio the right way.</a:t>
+              <a:t>Every blend on the curve beats holding equities alone, and the benefit keeps building until past half the portfolio (downside risk bottoms near 60%). That is a directional case to size up — not a target: a 59% position would breach concentration and liquidity discipline. A ~10% indicative sleeve already moves the portfolio the right way, with ample room to spare.</a:t>
             </a:r>
           </a:p>
         </p:txBody>
@@ -23256,7 +23256,7 @@
                 </a:solidFill>
                 <a:latin typeface="Arial"/>
               </a:rPr>
-              <a:t>The blend is not a trade-off: every allocation raises return and lowers downside risk — so to a committee this is a mathematical risk-reduction tool, not a risky bet, sized within prudent 3–8% limits.</a:t>
+              <a:t>The blend is not a trade-off: every allocation raises return and lowers downside risk — so to a committee this is a mathematical risk-reduction tool, not a risky bet. A ~10% indicative sleeve lifts return ~1.5 pts while cutting downside risk.</a:t>
             </a:r>
           </a:p>
         </p:txBody>

</xml_diff>

<commit_message>
Slide 20: lock the 10% blend to exact figures from the monthly track record
Computed the monthly-rebalanced frontier from AIP + MSCI World IMI monthly
net returns (SEK, 233 months, 2006-2025). Endpoints reproduce the chart
(MSCI 6.07%/11.53%, AIP 16.7%/10.89%, min-risk ~59%).
- 10% blend now exact: 7.3% return / 11.1% downside risk (was interpolated 7.6/11.0)
- Repositioned the on-curve 10% marker to the computed point
- Caption: ~10% sleeve lifts return ~1.2 pts, cuts downside risk ~0.4 pts
- Source line cites MSCI World IMI monthly and the downside-deviation method

https://claude.ai/code/session_01HRMxSvt6t94q3GFGUqavQe
</commit_message>
<xml_diff>
--- a/Your_index_is_now_a_bet_on_AI_diversify_it.pptx
+++ b/Your_index_is_now_a_bet_on_AI_diversify_it.pptx
@@ -23034,7 +23034,7 @@
                 </a:solidFill>
                 <a:latin typeface="Times New Roman"/>
               </a:rPr>
-              <a:t>7.6% return   ·   11.0% downside risk</a:t>
+              <a:t>7.3% return   ·   11.1% downside risk</a:t>
             </a:r>
             <a:r>
               <a:rPr sz="960">
@@ -23256,7 +23256,7 @@
                 </a:solidFill>
                 <a:latin typeface="Arial"/>
               </a:rPr>
-              <a:t>The blend is not a trade-off: every allocation raises return and lowers downside risk — so to a committee this is a mathematical risk-reduction tool, not a risky bet. A ~10% indicative sleeve lifts return ~1.5 pts while cutting downside risk.</a:t>
+              <a:t>The blend is not a trade-off: every allocation raises return and lowers downside risk — so to a committee this is a mathematical risk-reduction tool, not a risky bet. A ~10% indicative sleeve lifts return ~1.2 pts while cutting downside risk ~0.4 pts.</a:t>
             </a:r>
           </a:p>
         </p:txBody>
@@ -23298,7 +23298,7 @@
                 </a:solidFill>
                 <a:latin typeface="Arial"/>
               </a:rPr>
-              <a:t>Source: monthly net returns, 235 months (2006–2025), monthly rebalanced blends. The minimum-risk point is in-sample and shown for shape, not as advice. Illustrative; past performance is not indicative of future results.</a:t>
+              <a:t>Source: Athanase (AIP) and MSCI World IMI monthly net returns (SEK), 233 months 2006–2025 (ex-2014 H2 fund-transition gap), monthly-rebalanced blends; downside volatility = annualised downside deviation below zero. Minimum-risk point is in-sample, shown for shape, not advice. Past performance is not indicative of future results.</a:t>
             </a:r>
           </a:p>
         </p:txBody>

</xml_diff>

<commit_message>
Slide 20: cleaner marker leaders + add 20% allocation comparison
- Replaced the faint curved connector with crisp straight leaders to the
  10% and 20% markers (both as clear rings on the curve)
- Added the 20% blend point (exact: 8.5% return / 10.8% downside risk)
- Restructured the right column into three compact comparison cards:
  100% equities (6.1/11.5), +10% (7.3/11.1), +20% (8.5/10.8), with mix
- Updated 'how to read it' and caption to compare 10% vs 20%

https://claude.ai/code/session_01HRMxSvt6t94q3GFGUqavQe
</commit_message>
<xml_diff>
--- a/Your_index_is_now_a_bet_on_AI_diversify_it.pptx
+++ b/Your_index_is_now_a_bet_on_AI_diversify_it.pptx
@@ -22744,8 +22744,8 @@
         </p:nvSpPr>
         <p:spPr>
           <a:xfrm>
-            <a:off x="6510690" y="2262835"/>
-            <a:ext cx="2816422" cy="1170432"/>
+            <a:off x="6510690" y="2286000"/>
+            <a:ext cx="2816422" cy="731520"/>
           </a:xfrm>
           <a:prstGeom prst="rect">
             <a:avLst/>
@@ -22789,7 +22789,7 @@
         </p:nvSpPr>
         <p:spPr>
           <a:xfrm>
-            <a:off x="6671629" y="2379878"/>
+            <a:off x="6671629" y="2359152"/>
             <a:ext cx="2494545" cy="243840"/>
           </a:xfrm>
           <a:prstGeom prst="rect">
@@ -22831,7 +22831,7 @@
         </p:nvSpPr>
         <p:spPr>
           <a:xfrm>
-            <a:off x="6671629" y="2633472"/>
+            <a:off x="6671629" y="2587752"/>
             <a:ext cx="2494545" cy="438912"/>
           </a:xfrm>
           <a:prstGeom prst="rect">
@@ -22851,64 +22851,22 @@
               </a:spcAft>
             </a:pPr>
             <a:r>
-              <a:rPr sz="1280" b="1">
+              <a:rPr sz="1200" b="1">
                 <a:solidFill>
                   <a:srgbClr val="314359"/>
                 </a:solidFill>
                 <a:latin typeface="Times New Roman"/>
               </a:rPr>
-              <a:t>6.1% return</a:t>
-            </a:r>
-            <a:r>
-              <a:rPr sz="960">
+              <a:t>6.1% return   ·   11.5% downside risk</a:t>
+            </a:r>
+            <a:r>
+              <a:rPr sz="1200">
                 <a:solidFill>
                   <a:srgbClr val="314359"/>
                 </a:solidFill>
                 <a:latin typeface="Arial"/>
               </a:rPr>
-              <a:t>   ·   11.5% downside risk</a:t>
-            </a:r>
-          </a:p>
-        </p:txBody>
-      </p:sp>
-      <p:sp>
-        <p:nvSpPr>
-          <p:cNvPr id="14" name="TextBox 13"/>
-          <p:cNvSpPr txBox="1"/>
-          <p:nvPr/>
-        </p:nvSpPr>
-        <p:spPr>
-          <a:xfrm>
-            <a:off x="6671629" y="3062630"/>
-            <a:ext cx="2494545" cy="292608"/>
-          </a:xfrm>
-          <a:prstGeom prst="rect">
-            <a:avLst/>
-          </a:prstGeom>
-          <a:noFill/>
-        </p:spPr>
-        <p:txBody>
-          <a:bodyPr wrap="square" lIns="0" tIns="0" rIns="0" bIns="0" anchor="t">
-            <a:spAutoFit/>
-          </a:bodyPr>
-          <a:lstStyle/>
-          <a:p>
-            <a:pPr algn="l">
-              <a:lnSpc>
-                <a:spcPct val="110000"/>
-              </a:lnSpc>
-              <a:spcAft>
-                <a:spcPts val="0"/>
-              </a:spcAft>
-            </a:pPr>
-            <a:r>
-              <a:rPr sz="840" b="0" i="0">
-                <a:solidFill>
-                  <a:srgbClr val="0E1620"/>
-                </a:solidFill>
-                <a:latin typeface="Arial"/>
-              </a:rPr>
-              <a:t>100% MSCI World IMI</a:t>
+              <a:t/>
             </a:r>
           </a:p>
         </p:txBody>
@@ -22921,8 +22879,8 @@
         </p:nvSpPr>
         <p:spPr>
           <a:xfrm>
-            <a:off x="6510690" y="3569817"/>
-            <a:ext cx="2816422" cy="1170432"/>
+            <a:off x="6510690" y="3090672"/>
+            <a:ext cx="2816422" cy="731520"/>
           </a:xfrm>
           <a:prstGeom prst="rect">
             <a:avLst/>
@@ -22966,7 +22924,7 @@
         </p:nvSpPr>
         <p:spPr>
           <a:xfrm>
-            <a:off x="6671629" y="3686860"/>
+            <a:off x="6671629" y="3163824"/>
             <a:ext cx="2494545" cy="243840"/>
           </a:xfrm>
           <a:prstGeom prst="rect">
@@ -22995,7 +22953,7 @@
                 </a:solidFill>
                 <a:latin typeface="Arial"/>
               </a:rPr>
-              <a:t>ADD A 10% SLEEVE</a:t>
+              <a:t>ADD A 10% SLEEVE      ·      90 / 10</a:t>
             </a:r>
           </a:p>
         </p:txBody>
@@ -23008,7 +22966,7 @@
         </p:nvSpPr>
         <p:spPr>
           <a:xfrm>
-            <a:off x="6671629" y="3940454"/>
+            <a:off x="6671629" y="3392424"/>
             <a:ext cx="2494545" cy="438912"/>
           </a:xfrm>
           <a:prstGeom prst="rect">
@@ -23028,7 +22986,7 @@
               </a:spcAft>
             </a:pPr>
             <a:r>
-              <a:rPr sz="1280" b="1">
+              <a:rPr sz="1200" b="1">
                 <a:solidFill>
                   <a:srgbClr val="314359"/>
                 </a:solidFill>
@@ -23037,55 +22995,13 @@
               <a:t>7.3% return   ·   11.1% downside risk</a:t>
             </a:r>
             <a:r>
-              <a:rPr sz="960">
+              <a:rPr sz="1200">
                 <a:solidFill>
                   <a:srgbClr val="314359"/>
                 </a:solidFill>
                 <a:latin typeface="Arial"/>
               </a:rPr>
               <a:t/>
-            </a:r>
-          </a:p>
-        </p:txBody>
-      </p:sp>
-      <p:sp>
-        <p:nvSpPr>
-          <p:cNvPr id="18" name="TextBox 17"/>
-          <p:cNvSpPr txBox="1"/>
-          <p:nvPr/>
-        </p:nvSpPr>
-        <p:spPr>
-          <a:xfrm>
-            <a:off x="6671629" y="4369612"/>
-            <a:ext cx="2494545" cy="292608"/>
-          </a:xfrm>
-          <a:prstGeom prst="rect">
-            <a:avLst/>
-          </a:prstGeom>
-          <a:noFill/>
-        </p:spPr>
-        <p:txBody>
-          <a:bodyPr wrap="square" lIns="0" tIns="0" rIns="0" bIns="0" anchor="t">
-            <a:spAutoFit/>
-          </a:bodyPr>
-          <a:lstStyle/>
-          <a:p>
-            <a:pPr algn="l">
-              <a:lnSpc>
-                <a:spcPct val="110000"/>
-              </a:lnSpc>
-              <a:spcAft>
-                <a:spcPts val="0"/>
-              </a:spcAft>
-            </a:pPr>
-            <a:r>
-              <a:rPr sz="840" b="0" i="0">
-                <a:solidFill>
-                  <a:srgbClr val="0E1620"/>
-                </a:solidFill>
-                <a:latin typeface="Arial"/>
-              </a:rPr>
-              <a:t>90% MSCI  /  10% Athanase</a:t>
             </a:r>
           </a:p>
         </p:txBody>
@@ -23169,7 +23085,7 @@
                 </a:solidFill>
                 <a:latin typeface="Arial"/>
               </a:rPr>
-              <a:t>Every blend on the curve beats holding equities alone, and the benefit keeps building until past half the portfolio (downside risk bottoms near 60%). That is a directional case to size up — not a target: a 59% position would breach concentration and liquidity discipline. A ~10% indicative sleeve already moves the portfolio the right way, with ample room to spare.</a:t>
+              <a:t>Every blend beats equities alone, and the benefit builds toward the ~60% minimum-risk point. A 10% sleeve lifts return ~1.2 pts with less downside; doubling to 20% roughly doubles the return pickup (~+2.4 pts) and cuts risk further — still far from any concentration limit.</a:t>
             </a:r>
           </a:p>
         </p:txBody>
@@ -23256,7 +23172,7 @@
                 </a:solidFill>
                 <a:latin typeface="Arial"/>
               </a:rPr>
-              <a:t>The blend is not a trade-off: every allocation raises return and lowers downside risk — so to a committee this is a mathematical risk-reduction tool, not a risky bet. A ~10% indicative sleeve lifts return ~1.2 pts while cutting downside risk ~0.4 pts.</a:t>
+              <a:t>The blend is not a trade-off: every allocation raises return and lowers downside risk — a mathematical risk-reduction tool, not a risky bet. A ~10% sleeve adds ~1.2 pts of return and ~0.4 pts less downside risk; a ~20% sleeve roughly doubles both.</a:t>
             </a:r>
           </a:p>
         </p:txBody>
@@ -23299,6 +23215,141 @@
                 <a:latin typeface="Arial"/>
               </a:rPr>
               <a:t>Source: Athanase (AIP) and MSCI World IMI monthly net returns (SEK), 233 months 2006–2025 (ex-2014 H2 fund-transition gap), monthly-rebalanced blends; downside volatility = annualised downside deviation below zero. Minimum-risk point is in-sample, shown for shape, not advice. Past performance is not indicative of future results.</a:t>
+            </a:r>
+          </a:p>
+        </p:txBody>
+      </p:sp>
+      <p:sp>
+        <p:nvSpPr>
+          <p:cNvPr id="24" name="Rectangle 14"/>
+          <p:cNvSpPr/>
+          <p:nvPr/>
+        </p:nvSpPr>
+        <p:spPr>
+          <a:xfrm>
+            <a:off x="6510690" y="3895344"/>
+            <a:ext cx="2816422" cy="731520"/>
+          </a:xfrm>
+          <a:prstGeom prst="rect">
+            <a:avLst/>
+          </a:prstGeom>
+          <a:solidFill>
+            <a:srgbClr val="F6F7F9"/>
+          </a:solidFill>
+          <a:ln>
+            <a:noFill/>
+          </a:ln>
+          <a:effectLst/>
+        </p:spPr>
+        <p:style>
+          <a:lnRef idx="1">
+            <a:schemeClr val="accent1"/>
+          </a:lnRef>
+          <a:fillRef idx="3">
+            <a:schemeClr val="accent1"/>
+          </a:fillRef>
+          <a:effectRef idx="2">
+            <a:schemeClr val="accent1"/>
+          </a:effectRef>
+          <a:fontRef idx="minor">
+            <a:schemeClr val="lt1"/>
+          </a:fontRef>
+        </p:style>
+        <p:txBody>
+          <a:bodyPr rtlCol="0" anchor="ctr"/>
+          <a:lstStyle/>
+          <a:p>
+            <a:pPr algn="ctr"/>
+            <a:endParaRPr/>
+          </a:p>
+        </p:txBody>
+      </p:sp>
+      <p:sp>
+        <p:nvSpPr>
+          <p:cNvPr id="25" name="TextBox 15"/>
+          <p:cNvSpPr txBox="1"/>
+          <p:nvPr/>
+        </p:nvSpPr>
+        <p:spPr>
+          <a:xfrm>
+            <a:off x="6671629" y="3968496"/>
+            <a:ext cx="2494545" cy="243840"/>
+          </a:xfrm>
+          <a:prstGeom prst="rect">
+            <a:avLst/>
+          </a:prstGeom>
+          <a:noFill/>
+        </p:spPr>
+        <p:txBody>
+          <a:bodyPr wrap="square" lIns="0" tIns="0" rIns="0" bIns="0" anchor="t">
+            <a:spAutoFit/>
+          </a:bodyPr>
+          <a:lstStyle/>
+          <a:p>
+            <a:pPr algn="l">
+              <a:lnSpc>
+                <a:spcPct val="110000"/>
+              </a:lnSpc>
+              <a:spcAft>
+                <a:spcPts val="0"/>
+              </a:spcAft>
+            </a:pPr>
+            <a:r>
+              <a:rPr sz="840" b="1" i="0">
+                <a:solidFill>
+                  <a:srgbClr val="314359"/>
+                </a:solidFill>
+                <a:latin typeface="Arial"/>
+              </a:rPr>
+              <a:t>ADD A 20% SLEEVE      ·      80 / 20</a:t>
+            </a:r>
+          </a:p>
+        </p:txBody>
+      </p:sp>
+      <p:sp>
+        <p:nvSpPr>
+          <p:cNvPr id="26" name="TextBox 16"/>
+          <p:cNvSpPr txBox="1"/>
+          <p:nvPr/>
+        </p:nvSpPr>
+        <p:spPr>
+          <a:xfrm>
+            <a:off x="6671629" y="4197096"/>
+            <a:ext cx="2494545" cy="438912"/>
+          </a:xfrm>
+          <a:prstGeom prst="rect">
+            <a:avLst/>
+          </a:prstGeom>
+          <a:noFill/>
+        </p:spPr>
+        <p:txBody>
+          <a:bodyPr wrap="square" lIns="0" tIns="0" rIns="0" bIns="0" anchor="t">
+            <a:spAutoFit/>
+          </a:bodyPr>
+          <a:lstStyle/>
+          <a:p>
+            <a:pPr>
+              <a:spcAft>
+                <a:spcPts val="0"/>
+              </a:spcAft>
+            </a:pPr>
+            <a:r>
+              <a:rPr sz="1200" b="1">
+                <a:solidFill>
+                  <a:srgbClr val="314359"/>
+                </a:solidFill>
+                <a:latin typeface="Times New Roman"/>
+              </a:rPr>
+              <a:t>8.5% return   ·   10.8% downside risk</a:t>
+            </a:r>
+            <a:r>
+              <a:rPr sz="1200">
+                <a:solidFill>
+                  <a:srgbClr val="314359"/>
+                </a:solidFill>
+                <a:latin typeface="Arial"/>
+              </a:rPr>
+              <a:t/>
             </a:r>
           </a:p>
         </p:txBody>

</xml_diff>

<commit_message>
Title slide: 'UK Investment Trust Proposal'
https://claude.ai/code/session_01HRMxSvt6t94q3GFGUqavQe
</commit_message>
<xml_diff>
--- a/Your_index_is_now_a_bet_on_AI_diversify_it.pptx
+++ b/Your_index_is_now_a_bet_on_AI_diversify_it.pptx
@@ -4494,17 +4494,7 @@
                 </a:solidFill>
                 <a:latin typeface="Times New Roman"/>
               </a:rPr>
-              <a:t>Your index is now a bet on AI</a:t>
-            </a:r>
-            <a:br/>
-            <a:r>
-              <a:rPr lang="en-GB" sz="3360" spc="-126" dirty="0">
-                <a:solidFill>
-                  <a:srgbClr val="FFFFFF"/>
-                </a:solidFill>
-                <a:latin typeface="Times New Roman"/>
-              </a:rPr>
-              <a:t>— diversify it</a:t>
+              <a:t>UK Investment Trust Proposal</a:t>
             </a:r>
           </a:p>
           <a:p>

</xml_diff>